<commit_message>
Repair FreeP PowerPoint corpus fixtures
</commit_message>
<xml_diff>
--- a/tools/FreeP.RenderCompare/corpus/21-comments-notes.pptx
+++ b/tools/FreeP.RenderCompare/corpus/21-comments-notes.pptx
@@ -22,7 +22,7 @@
 
 <file path=ppt/comments/comment1.xml><?xml version="1.0" encoding="utf-8"?>
 <p:cmLst xmlns:p="http://schemas.openxmlformats.org/presentationml/2006/main" xmlns:a="http://schemas.openxmlformats.org/drawingml/2006/main" xmlns:r="http://schemas.openxmlformats.org/officeDocument/2006/relationships">
-  <p:cm authorId="0" dt="2026-07-14T17:43:05" idx="1">
+  <p:cm authorId="0" dt="2026-07-14T08:55:58" idx="1">
     <p:pos x="914400" y="457200"/>
     <p:text>Confirm the title before publishing.</p:text>
   </p:cm>
@@ -31,11 +31,11 @@
 
 <file path=ppt/comments/comment2.xml><?xml version="1.0" encoding="utf-8"?>
 <p:cmLst xmlns:p="http://schemas.openxmlformats.org/presentationml/2006/main" xmlns:a="http://schemas.openxmlformats.org/drawingml/2006/main" xmlns:r="http://schemas.openxmlformats.org/officeDocument/2006/relationships">
-  <p:cm authorId="1" dt="2026-07-14T17:43:05" idx="1">
+  <p:cm authorId="1" dt="2026-07-14T08:55:58" idx="1">
     <p:pos x="1371600" y="914400"/>
     <p:text>Add a data source footnote.</p:text>
   </p:cm>
-  <p:cm authorId="0" dt="2026-07-14T17:43:05" idx="2">
+  <p:cm authorId="0" dt="2026-07-14T08:55:58" idx="2">
     <p:pos x="2743200" y="1371600"/>
     <p:text>Keep this callout for presenter notes.</p:text>
   </p:cm>

</xml_diff>